<commit_message>
image not render issue fail for in class ppt
</commit_message>
<xml_diff>
--- a/Educational-Facilitation-System 1.pptx
+++ b/Educational-Facilitation-System 1.pptx
@@ -139,6 +139,7 @@
 <p1510:revInfo xmlns:a="http://schemas.openxmlformats.org/drawingml/2006/main" xmlns:r="http://schemas.openxmlformats.org/officeDocument/2006/relationships" xmlns:p1510="http://schemas.microsoft.com/office/powerpoint/2015/10/main">
   <p1510:revLst>
     <p1510:client id="{A2ADD073-C157-9D48-19BD-DBA86649037A}" v="50" dt="2026-04-26T15:39:09.074"/>
+    <p1510:client id="{CD88E346-F4D5-EF56-D11D-C8AEDFCAF1FE}" v="16" dt="2026-04-26T16:25:44.591"/>
   </p1510:revLst>
 </p1510:revInfo>
 </file>
@@ -639,7 +640,7 @@
           <a:p>
             <a:fld id="{F7021451-1387-4CA6-816F-3879F97B5CBC}" type="slidenum">
               <a:rPr lang="en-US"/>
-              <a:t>10</a:t>
+              <a:t>11</a:t>
             </a:fld>
             <a:endParaRPr lang="en-US"/>
           </a:p>
@@ -807,7 +808,7 @@
           <a:p>
             <a:fld id="{F7021451-1387-4CA6-816F-3879F97B5CBC}" type="slidenum">
               <a:rPr lang="en-US"/>
-              <a:t>3</a:t>
+              <a:t>4</a:t>
             </a:fld>
             <a:endParaRPr lang="en-US"/>
           </a:p>
@@ -891,7 +892,7 @@
           <a:p>
             <a:fld id="{F7021451-1387-4CA6-816F-3879F97B5CBC}" type="slidenum">
               <a:rPr lang="en-US"/>
-              <a:t>4</a:t>
+              <a:t>5</a:t>
             </a:fld>
             <a:endParaRPr lang="en-US"/>
           </a:p>
@@ -975,7 +976,7 @@
           <a:p>
             <a:fld id="{F7021451-1387-4CA6-816F-3879F97B5CBC}" type="slidenum">
               <a:rPr lang="en-US"/>
-              <a:t>5</a:t>
+              <a:t>6</a:t>
             </a:fld>
             <a:endParaRPr lang="en-US"/>
           </a:p>
@@ -1059,7 +1060,7 @@
           <a:p>
             <a:fld id="{F7021451-1387-4CA6-816F-3879F97B5CBC}" type="slidenum">
               <a:rPr lang="en-US"/>
-              <a:t>6</a:t>
+              <a:t>7</a:t>
             </a:fld>
             <a:endParaRPr lang="en-US"/>
           </a:p>
@@ -1143,7 +1144,7 @@
           <a:p>
             <a:fld id="{F7021451-1387-4CA6-816F-3879F97B5CBC}" type="slidenum">
               <a:rPr lang="en-US"/>
-              <a:t>7</a:t>
+              <a:t>8</a:t>
             </a:fld>
             <a:endParaRPr lang="en-US"/>
           </a:p>
@@ -1227,7 +1228,7 @@
           <a:p>
             <a:fld id="{F7021451-1387-4CA6-816F-3879F97B5CBC}" type="slidenum">
               <a:rPr lang="en-US"/>
-              <a:t>8</a:t>
+              <a:t>9</a:t>
             </a:fld>
             <a:endParaRPr lang="en-US"/>
           </a:p>
@@ -1311,7 +1312,7 @@
           <a:p>
             <a:fld id="{F7021451-1387-4CA6-816F-3879F97B5CBC}" type="slidenum">
               <a:rPr lang="en-US"/>
-              <a:t>9</a:t>
+              <a:t>10</a:t>
             </a:fld>
             <a:endParaRPr lang="en-US"/>
           </a:p>
@@ -3529,50 +3530,6 @@
       </p:pic>
       <p:sp>
         <p:nvSpPr>
-          <p:cNvPr id="3" name="Shape 0"/>
-          <p:cNvSpPr/>
-          <p:nvPr/>
-        </p:nvSpPr>
-        <p:spPr>
-          <a:xfrm>
-            <a:off x="9144000" y="0"/>
-            <a:ext cx="5486400" cy="8229600"/>
-          </a:xfrm>
-          <a:prstGeom prst="rect">
-            <a:avLst/>
-          </a:prstGeom>
-          <a:solidFill>
-            <a:srgbClr val="DFDFE0"/>
-          </a:solidFill>
-          <a:ln/>
-        </p:spPr>
-      </p:sp>
-      <p:pic>
-        <p:nvPicPr>
-          <p:cNvPr id="4" name="Image 1" descr="preencoded.png"/>
-          <p:cNvPicPr>
-            <a:picLocks noChangeAspect="1"/>
-          </p:cNvPicPr>
-          <p:nvPr/>
-        </p:nvPicPr>
-        <p:blipFill>
-          <a:blip r:embed="rId4"/>
-          <a:stretch>
-            <a:fillRect/>
-          </a:stretch>
-        </p:blipFill>
-        <p:spPr>
-          <a:xfrm>
-            <a:off x="9144000" y="0"/>
-            <a:ext cx="5486400" cy="8229600"/>
-          </a:xfrm>
-          <a:prstGeom prst="rect">
-            <a:avLst/>
-          </a:prstGeom>
-        </p:spPr>
-      </p:pic>
-      <p:sp>
-        <p:nvSpPr>
           <p:cNvPr id="5" name="Text 1"/>
           <p:cNvSpPr/>
           <p:nvPr/>
@@ -4275,7 +4232,7 @@
                 <a:latin typeface="Funnel Sans" pitchFamily="34" charset="0"/>
                 <a:ea typeface="Funnel Sans" pitchFamily="34" charset="-122"/>
                 <a:cs typeface="Funnel Sans" pitchFamily="34" charset="-120"/>
-                <a:hlinkClick r:id="rId5">
+                <a:hlinkClick r:id="rId4">
                   <a:extLst>
                     <a:ext uri="{A12FA001-AC4F-418D-AE19-62706E023703}">
                       <ahyp:hlinkClr xmlns:ahyp="http://schemas.microsoft.com/office/drawing/2018/hyperlinkcolor" val="tx"/>
@@ -4300,6 +4257,36 @@
           </a:p>
         </p:txBody>
       </p:sp>
+      <p:pic>
+        <p:nvPicPr>
+          <p:cNvPr id="20" name="Picture 19" descr="A screenshot of a login screen&#10;&#10;AI-generated content may be incorrect.">
+            <a:extLst>
+              <a:ext uri="{FF2B5EF4-FFF2-40B4-BE49-F238E27FC236}">
+                <a16:creationId xmlns:a16="http://schemas.microsoft.com/office/drawing/2014/main" id="{58B32452-F8FB-6520-D582-D89D4C03701B}"/>
+              </a:ext>
+            </a:extLst>
+          </p:cNvPr>
+          <p:cNvPicPr>
+            <a:picLocks noChangeAspect="1"/>
+          </p:cNvPicPr>
+          <p:nvPr/>
+        </p:nvPicPr>
+        <p:blipFill>
+          <a:blip r:embed="rId5"/>
+          <a:stretch>
+            <a:fillRect/>
+          </a:stretch>
+        </p:blipFill>
+        <p:spPr>
+          <a:xfrm>
+            <a:off x="8433058" y="302342"/>
+            <a:ext cx="5920144" cy="7779775"/>
+          </a:xfrm>
+          <a:prstGeom prst="rect">
+            <a:avLst/>
+          </a:prstGeom>
+        </p:spPr>
+      </p:pic>
     </p:spTree>
   </p:cSld>
   <p:clrMapOvr>
@@ -5095,50 +5082,6 @@
       </p:pic>
       <p:sp>
         <p:nvSpPr>
-          <p:cNvPr id="3" name="Shape 0"/>
-          <p:cNvSpPr/>
-          <p:nvPr/>
-        </p:nvSpPr>
-        <p:spPr>
-          <a:xfrm>
-            <a:off x="0" y="0"/>
-            <a:ext cx="5486400" cy="8229600"/>
-          </a:xfrm>
-          <a:prstGeom prst="rect">
-            <a:avLst/>
-          </a:prstGeom>
-          <a:solidFill>
-            <a:srgbClr val="DFDFE0"/>
-          </a:solidFill>
-          <a:ln/>
-        </p:spPr>
-      </p:sp>
-      <p:pic>
-        <p:nvPicPr>
-          <p:cNvPr id="4" name="Image 1" descr="preencoded.png"/>
-          <p:cNvPicPr>
-            <a:picLocks noChangeAspect="1"/>
-          </p:cNvPicPr>
-          <p:nvPr/>
-        </p:nvPicPr>
-        <p:blipFill>
-          <a:blip r:embed="rId4"/>
-          <a:stretch>
-            <a:fillRect/>
-          </a:stretch>
-        </p:blipFill>
-        <p:spPr>
-          <a:xfrm>
-            <a:off x="0" y="0"/>
-            <a:ext cx="5486400" cy="8229600"/>
-          </a:xfrm>
-          <a:prstGeom prst="rect">
-            <a:avLst/>
-          </a:prstGeom>
-        </p:spPr>
-      </p:pic>
-      <p:sp>
-        <p:nvSpPr>
           <p:cNvPr id="5" name="Text 1"/>
           <p:cNvSpPr/>
           <p:nvPr/>
@@ -5751,6 +5694,36 @@
           </a:p>
         </p:txBody>
       </p:sp>
+      <p:pic>
+        <p:nvPicPr>
+          <p:cNvPr id="20" name="Picture 19" descr="A screenshot of a computer&#10;&#10;AI-generated content may be incorrect.">
+            <a:extLst>
+              <a:ext uri="{FF2B5EF4-FFF2-40B4-BE49-F238E27FC236}">
+                <a16:creationId xmlns:a16="http://schemas.microsoft.com/office/drawing/2014/main" id="{CEF5EBF4-5CE5-29D3-22D3-C87596D36A82}"/>
+              </a:ext>
+            </a:extLst>
+          </p:cNvPr>
+          <p:cNvPicPr>
+            <a:picLocks noChangeAspect="1"/>
+          </p:cNvPicPr>
+          <p:nvPr/>
+        </p:nvPicPr>
+        <p:blipFill>
+          <a:blip r:embed="rId4"/>
+          <a:stretch>
+            <a:fillRect/>
+          </a:stretch>
+        </p:blipFill>
+        <p:spPr>
+          <a:xfrm>
+            <a:off x="132736" y="-7374"/>
+            <a:ext cx="6142704" cy="8229600"/>
+          </a:xfrm>
+          <a:prstGeom prst="rect">
+            <a:avLst/>
+          </a:prstGeom>
+        </p:spPr>
+      </p:pic>
     </p:spTree>
   </p:cSld>
   <p:clrMapOvr>

</xml_diff>